<commit_message>
Standardize list capitalization and terminology
</commit_message>
<xml_diff>
--- a/Modul 1/slaid/Slaid-Modul-1-MPE.pptx
+++ b/Modul 1/slaid/Slaid-Modul-1-MPE.pptx
@@ -1755,7 +1755,7 @@
           <a:p>
             <a:r>
               <a:rPr lang="en-US" dirty="0"/>
-              <a:t>Rumusan: produktiviti tidak meningkat kerana lebih banyak aplikasi. Ia meningkat apabila data ditangkap dengan betul, kerja berulang dikurangkan, pengecualian kelihatan dan pegawai boleh membuat keputusan dengan yakin. Minta peserta melengkapkan exit ticket.</a:t>
+              <a:t>Rumusan: produktiviti tidak meningkat kerana lebih banyak aplikasi. Ia meningkat apabila data dikumpul dengan betul, kerja berulang dikurangkan, pengecualian kelihatan dan pegawai boleh membuat keputusan dengan yakin. Minta peserta melengkapkan exit ticket.</a:t>
             </a:r>
             <a:endParaRPr lang="en-US" dirty="0"/>
           </a:p>
@@ -2107,7 +2107,7 @@
           <a:p>
             <a:r>
               <a:rPr lang="en-US" dirty="0"/>
-              <a:t>Gunakan Buku Log sebagai contoh. Manual menggunakan catatan dan fail fizikal. Digital memindahkan borang ke skrin tetapi mungkin masih memerlukan salinan data. Pintar menangkap sekali, menyemak awal dan menyediakan status.</a:t>
+              <a:t>Gunakan Buku Log sebagai contoh. Manual menggunakan catatan dan fail fizikal. Digital memindahkan borang ke skrin tetapi mungkin masih memerlukan salinan data. Pintar mengumpul sekali, menyemak awal dan menyediakan status.</a:t>
             </a:r>
             <a:endParaRPr lang="en-US" dirty="0"/>
           </a:p>
@@ -5424,7 +5424,7 @@
                   <a:srgbClr val="182427"/>
                 </a:solidFill>
               </a:rPr>
-              <a:t>Menangkap</a:t>
+              <a:t>Mengumpul</a:t>
             </a:r>
             <a:endParaRPr lang="en-US" sz="1650" dirty="0"/>
           </a:p>
@@ -7127,7 +7127,7 @@
                   <a:srgbClr val="173440"/>
                 </a:solidFill>
               </a:rPr>
-              <a:t>MENANGKAP + MENYEMAK</a:t>
+              <a:t>MENGUMPUL + MENYEMAK</a:t>
             </a:r>
             <a:endParaRPr lang="en-US" sz="1220" dirty="0"/>
           </a:p>
@@ -11305,7 +11305,7 @@
                   <a:srgbClr val="BFD0D2"/>
                 </a:solidFill>
               </a:rPr>
-              <a:t>Tangkap data</a:t>
+              <a:t>Kumpul data</a:t>
             </a:r>
             <a:endParaRPr lang="en-US" sz="1250" dirty="0"/>
           </a:p>
@@ -15344,7 +15344,7 @@
                   <a:srgbClr val="6A777A"/>
                 </a:solidFill>
               </a:rPr>
-              <a:t>Data apa ditangkap sekali?</a:t>
+              <a:t>Data apa dikumpul sekali?</a:t>
             </a:r>
             <a:endParaRPr lang="en-US" sz="1150" dirty="0"/>
           </a:p>
@@ -22568,7 +22568,7 @@
                   <a:srgbClr val="FFFFFF"/>
                 </a:solidFill>
               </a:rPr>
-              <a:t>Tangkap data sekali, gunakan berkali-kali.</a:t>
+              <a:t>Kumpul data sekali, gunakan berkali-kali.</a:t>
             </a:r>
             <a:endParaRPr lang="en-US" sz="1700" dirty="0"/>
           </a:p>
@@ -26304,7 +26304,7 @@
                   <a:srgbClr val="FFFFFF"/>
                 </a:solidFill>
               </a:rPr>
-              <a:t>Aplikasi pintar menggunakan data, peraturan atau AI untuk membantu manusia menangkap, menyusun, menyemak, melaksanakan dan memantau kerja dengan lebih konsisten.</a:t>
+              <a:t>Aplikasi pintar menggunakan data, peraturan atau AI untuk membantu manusia mengumpul, menyusun, menyemak, melaksanakan dan memantau kerja dengan lebih konsisten.</a:t>
             </a:r>
             <a:endParaRPr lang="en-US" sz="1800" dirty="0"/>
           </a:p>
@@ -28232,7 +28232,7 @@
                   <a:srgbClr val="182427"/>
                 </a:solidFill>
               </a:rPr>
-              <a:t>Tangkap sekali</a:t>
+              <a:t>Kumpul sekali</a:t>
             </a:r>
             <a:endParaRPr lang="en-US" sz="1300" dirty="0"/>
           </a:p>
@@ -30631,7 +30631,7 @@
                   <a:srgbClr val="FFFFFF"/>
                 </a:solidFill>
               </a:rPr>
-              <a:t>Prinsip: tangkap data di punca dan kurangkan pemindahan yang tidak menambah nilai.</a:t>
+              <a:t>Prinsip: kumpul data di punca dan kurangkan pemindahan yang tidak menambah nilai.</a:t>
             </a:r>
             <a:endParaRPr lang="en-US" sz="1350" dirty="0"/>
           </a:p>

</xml_diff>